<commit_message>
docs: retirer les references au depot des livrables
Le rapport et les diapositives ne mentionnent plus l'adresse du depot ni la
carte de ses dossiers. La procedure de reproduction est conservee en annexe :
le sujet demande un document permettant de relancer les mesures.

Le PDF des diapositives est supprime : la presentation se rend en .pptx.
</commit_message>
<xml_diff>
--- a/Soutenance_DRL.pptx
+++ b/Soutenance_DRL.pptx
@@ -3319,25 +3319,6 @@
               <a:t>[compléter les noms complets]</a:t>
             </a:r>
           </a:p>
-          <a:p>
-            <a:pPr algn="ctr">
-              <a:spcBef>
-                <a:spcPts val="0"/>
-              </a:spcBef>
-              <a:spcAft>
-                <a:spcPts val="600"/>
-              </a:spcAft>
-            </a:pPr>
-            <a:r>
-              <a:rPr sz="1200" b="0" i="0">
-                <a:solidFill>
-                  <a:srgbClr val="606674"/>
-                </a:solidFill>
-                <a:latin typeface="Calibri"/>
-              </a:rPr>
-              <a:t>github.com/KaabiOmar/drl-project</a:t>
-            </a:r>
-          </a:p>
         </p:txBody>
       </p:sp>
     </p:spTree>
@@ -12197,32 +12178,13 @@
               </a:spcAft>
             </a:pPr>
             <a:r>
-              <a:rPr sz="1500" b="0" i="0">
+              <a:rPr sz="1400" b="0" i="0">
                 <a:solidFill>
                   <a:srgbClr val="606674"/>
                 </a:solidFill>
                 <a:latin typeface="Calibri"/>
               </a:rPr>
-              <a:t>github.com/KaabiOmar/drl-project</a:t>
-            </a:r>
-          </a:p>
-          <a:p>
-            <a:pPr algn="ctr">
-              <a:spcBef>
-                <a:spcPts val="0"/>
-              </a:spcBef>
-              <a:spcAft>
-                <a:spcPts val="600"/>
-              </a:spcAft>
-            </a:pPr>
-            <a:r>
-              <a:rPr sz="1300" b="0" i="0">
-                <a:solidFill>
-                  <a:srgbClr val="606674"/>
-                </a:solidFill>
-                <a:latin typeface="Calibri"/>
-              </a:rPr>
-              <a:t>165 entraînements · 11 agents · 4 environnements · 30 tests unitaires</a:t>
+              <a:t>165 entraînements · 11 agents · 4 environnements · 3 graines</a:t>
             </a:r>
           </a:p>
         </p:txBody>

</xml_diff>

<commit_message>
docs: sommaire reel dans le rapport, marqueur de noms retire
Le sommaire etait un champ TOC de Word : vide tant que l'utilisateur ne met pas
les champs a jour, et vide dans le PDF produit par LibreOffice. Remplace par une
table des matieres statique, 26 entrees avec points de conduite et numeros de
page, plus un numero de page en pied de page.

Les numeros viennent d'une premiere conversion en PDF puis d'une recherche du
titre page par page ; un controle verifie que chaque entree pointe bien sur la
page ou le titre apparait. 26/26 coherentes.

Retire aussi le marqueur [a completer] de la page de titre et de la premiere
diapositive.
</commit_message>
<xml_diff>
--- a/Soutenance_DRL.pptx
+++ b/Soutenance_DRL.pptx
@@ -3287,7 +3287,7 @@
                 <a:spcPts val="0"/>
               </a:spcBef>
               <a:spcAft>
-                <a:spcPts val="300"/>
+                <a:spcPts val="800"/>
               </a:spcAft>
             </a:pPr>
             <a:r>
@@ -3298,25 +3298,6 @@
                 <a:latin typeface="Calibri"/>
               </a:rPr>
               <a:t>Omar Kaabi · Awatef B. · Viet Hoang</a:t>
-            </a:r>
-          </a:p>
-          <a:p>
-            <a:pPr algn="ctr">
-              <a:spcBef>
-                <a:spcPts val="0"/>
-              </a:spcBef>
-              <a:spcAft>
-                <a:spcPts val="800"/>
-              </a:spcAft>
-            </a:pPr>
-            <a:r>
-              <a:rPr sz="1100" b="0" i="1">
-                <a:solidFill>
-                  <a:srgbClr val="606674"/>
-                </a:solidFill>
-                <a:latin typeface="Calibri"/>
-              </a:rPr>
-              <a:t>[compléter les noms complets]</a:t>
             </a:r>
           </a:p>
         </p:txBody>

</xml_diff>